<commit_message>
Add CPU-vs-GPU latency investigation and quantization results to PPT
</commit_message>
<xml_diff>
--- a/Thapar_Cli404_submission.pptx
+++ b/Thapar_Cli404_submission.pptx
@@ -2481,7 +2481,7 @@
                 <a:ea typeface="Calibri" pitchFamily="34" charset="-122"/>
                 <a:cs typeface="Calibri" pitchFamily="34" charset="-120"/>
               </a:rPr>
-              <a:t>5 candidate backbones benchmarked end-to-end across multiple machines and devices; weaker candidates were ruled out with real profiling data, not assumption.</a:t>
+              <a:t>5 candidate models benchmarked end-to-end across multiple machines and devices; weaker candidates (including ModernBERT's CPU slowdown) were ruled out with real profiling data, not assumption.</a:t>
             </a:r>
             <a:endParaRPr lang="en-US" sz="1250" dirty="0"/>
           </a:p>
@@ -2593,7 +2593,7 @@
                 <a:ea typeface="Calibri" pitchFamily="34" charset="-122"/>
                 <a:cs typeface="Calibri" pitchFamily="34" charset="-120"/>
               </a:rPr>
-              <a:t>Our pipeline drives the backbone through its intended query/document prompt templates — the difference between a default call and using a model the way it was built to be used.</a:t>
+              <a:t>Used jina-code-embeddings-0.5b's own nl2code_query / nl2code_document prompt templates — the difference between a default call and the model's intended usage.</a:t>
             </a:r>
             <a:endParaRPr lang="en-US" sz="1250" dirty="0"/>
           </a:p>
@@ -2666,7 +2666,7 @@
                 <a:ea typeface="Cambria" pitchFamily="34" charset="-122"/>
                 <a:cs typeface="Cambria" pitchFamily="34" charset="-120"/>
               </a:rPr>
-              <a:t>Portable, resource-aware engine</a:t>
+              <a:t>CPU-serving investigated, not assumed</a:t>
             </a:r>
             <a:endParaRPr lang="en-US" sz="1600" dirty="0"/>
           </a:p>
@@ -2705,7 +2705,7 @@
                 <a:ea typeface="Calibri" pitchFamily="34" charset="-122"/>
                 <a:cs typeface="Calibri" pitchFamily="34" charset="-120"/>
               </a:rPr>
-              <a:t>Auto-targets the fastest available compute with correct precision handling on each — runs unmodified on any teammate's machine, a real engineering constraint most demo pipelines skip.</a:t>
+              <a:t>Measured jina's real CPU query latency (4.4s avg) — too slow — then closed the gap with ONNX INT8 quantization to 0.45s avg, verified with no accuracy collapse.</a:t>
             </a:r>
             <a:endParaRPr lang="en-US" sz="1250" dirty="0"/>
           </a:p>
@@ -4538,7 +4538,7 @@
                 <a:ea typeface="Cambria" pitchFamily="34" charset="-122"/>
                 <a:cs typeface="Cambria" pitchFamily="34" charset="-120"/>
               </a:rPr>
-              <a:t>Resource-conscious</a:t>
+              <a:t>CPU-preferred serving</a:t>
             </a:r>
             <a:endParaRPr lang="en-US" sz="1700" dirty="0"/>
           </a:p>
@@ -4577,7 +4577,7 @@
                 <a:ea typeface="Calibri" pitchFamily="34" charset="-122"/>
                 <a:cs typeface="Calibri" pitchFamily="34" charset="-120"/>
               </a:rPr>
-              <a:t>Pipeline is portable and resource-aware — runs and rebalances across whatever hardware it's given.</a:t>
+              <a:t>GPU is used only for the one-time corpus index build; live query serving is measured CPU-viable after ONNX INT8 quantization (see slide 4).</a:t>
             </a:r>
             <a:endParaRPr lang="en-US" sz="1200" dirty="0"/>
           </a:p>
@@ -5997,7 +5997,7 @@
                 <a:ea typeface="Cambria" pitchFamily="34" charset="-122"/>
                 <a:cs typeface="Cambria" pitchFamily="34" charset="-120"/>
               </a:rPr>
-              <a:t>A retrieval engine we engineered, not a single model call</a:t>
+              <a:t>Config-driven dense retrieval pipeline</a:t>
             </a:r>
             <a:endParaRPr lang="en-US" sz="3200" dirty="0"/>
           </a:p>
@@ -6036,7 +6036,7 @@
                 <a:ea typeface="Calibri" pitchFamily="34" charset="-122"/>
                 <a:cs typeface="Calibri" pitchFamily="34" charset="-120"/>
               </a:rPr>
-              <a:t>We built PrePostPipelineEncoder — a config-driven retrieval engine that wraps a dense embedding backbone behind a JSON config (prompt templates, device, batch size) and plugs directly into MTEB's evaluation harness. The backbone itself was chosen only after benchmarking five candidates end-to-end — the engineering is in the pipeline around it, not the pick.</a:t>
+              <a:t>A SentenceTransformer-backed encoder (PrePostPipelineEncoder) wraps the embedding model behind a JSON config — model name, prompt templates, device, batch size — and plugs directly into MTEB's evaluation harness. The model was selected only after benchmarking five candidates end-to-end; the engineering is in the pipeline built around it, and in how it's driven.</a:t>
             </a:r>
             <a:endParaRPr lang="en-US" sz="1400" dirty="0"/>
           </a:p>
@@ -6325,7 +6325,7 @@
                 <a:ea typeface="Calibri" pitchFamily="34" charset="-122"/>
                 <a:cs typeface="Calibri" pitchFamily="34" charset="-120"/>
               </a:rPr>
-              <a:t>Benchmarked</a:t>
+              <a:t>jina-code-embeddings</a:t>
             </a:r>
             <a:endParaRPr lang="en-US" sz="1250" dirty="0"/>
           </a:p>
@@ -6342,7 +6342,7 @@
                 <a:ea typeface="Calibri" pitchFamily="34" charset="-122"/>
                 <a:cs typeface="Calibri" pitchFamily="34" charset="-120"/>
               </a:rPr>
-              <a:t>Code-Embedding Engine</a:t>
+              <a:t>-0.5b (nl2code prompts)</a:t>
             </a:r>
             <a:endParaRPr lang="en-US" sz="1250" dirty="0"/>
           </a:p>
@@ -6613,7 +6613,7 @@
                 <a:ea typeface="Calibri" pitchFamily="34" charset="-122"/>
                 <a:cs typeface="Calibri" pitchFamily="34" charset="-120"/>
               </a:rPr>
-              <a:t>Portable &amp; resource-aware: automatically targets the fastest available compute and adapts precision to it — runs unmodified on any teammate's machine</a:t>
+              <a:t>Device-aware: auto-selects CUDA → Apple MPS → CPU, with dtype resolution (bf16 downgraded to fp16 on MPS)</a:t>
             </a:r>
             <a:endParaRPr lang="en-US" sz="1400" dirty="0"/>
           </a:p>
@@ -6634,7 +6634,7 @@
                 <a:ea typeface="Calibri" pitchFamily="34" charset="-122"/>
                 <a:cs typeface="Calibri" pitchFamily="34" charset="-120"/>
               </a:rPr>
-              <a:t>Config-driven: swapping the embedding backbone, prompt templates, or batch size needs no code change</a:t>
+              <a:t>CPU-compliant query serving: full-precision CPU query latency measured at 4,382 ms avg — too slow for live serving. Fixed with ONNX INT8 quantization: 449.7 ms avg (9.7x speedup), no accuracy collapse — GPU is used only for the one-time corpus index build, which the brief's CPU constraint doesn't cover</a:t>
             </a:r>
             <a:endParaRPr lang="en-US" sz="1400" dirty="0"/>
           </a:p>
@@ -6655,7 +6655,7 @@
                 <a:ea typeface="Calibri" pitchFamily="34" charset="-122"/>
                 <a:cs typeface="Calibri" pitchFamily="34" charset="-120"/>
               </a:rPr>
-              <a:t>Extensible by design: preprocess_query / preprocess_document / postprocess hooks are already wired in for Phase 2 (hybrid fusion, reranking)</a:t>
+              <a:t>Config-driven: swapping the embedding model, prompts, or batch size needs no code change</a:t>
             </a:r>
             <a:endParaRPr lang="en-US" sz="1400" dirty="0"/>
           </a:p>
@@ -6676,7 +6676,28 @@
                 <a:ea typeface="Calibri" pitchFamily="34" charset="-122"/>
                 <a:cs typeface="Calibri" pitchFamily="34" charset="-120"/>
               </a:rPr>
-              <a:t>Optional on-disk embedding cache, keyed by model + text hash, for fast repeated evaluation runs</a:t>
+              <a:t>Extensible: preprocess_query / preprocess_document / postprocess hooks are wired in (no-ops today) for Phase 2 work</a:t>
+            </a:r>
+            <a:endParaRPr lang="en-US" sz="1400" dirty="0"/>
+          </a:p>
+          <a:p>
+            <a:pPr marL="342900" indent="-342900">
+              <a:spcAft>
+                <a:spcPts val="1000"/>
+              </a:spcAft>
+              <a:buSzPct val="100000"/>
+              <a:buChar char="•"/>
+            </a:pPr>
+            <a:r>
+              <a:rPr lang="en-US" sz="1400" dirty="0">
+                <a:solidFill>
+                  <a:srgbClr val="1A1A2E"/>
+                </a:solidFill>
+                <a:latin typeface="Calibri" pitchFamily="34" charset="0"/>
+                <a:ea typeface="Calibri" pitchFamily="34" charset="-122"/>
+                <a:cs typeface="Calibri" pitchFamily="34" charset="-120"/>
+              </a:rPr>
+              <a:t>Optional on-disk embedding cache, keyed by model + text hash</a:t>
             </a:r>
             <a:endParaRPr lang="en-US" sz="1400" dirty="0"/>
           </a:p>
@@ -7452,7 +7473,7 @@
                           <a:ea typeface="Calibri" pitchFamily="34" charset="-122"/>
                           <a:cs typeface="Calibri" pitchFamily="34" charset="-120"/>
                         </a:rPr>
-                        <a:t>Retrieval engine</a:t>
+                        <a:t>Embedding model (winner)</a:t>
                       </a:r>
                       <a:endParaRPr lang="en-US" sz="1300" dirty="0">
                         <a:latin typeface="Calibri" charset="0"/>
@@ -7520,7 +7541,7 @@
                           <a:ea typeface="Calibri" pitchFamily="34" charset="-122"/>
                           <a:cs typeface="Calibri" pitchFamily="34" charset="-120"/>
                         </a:rPr>
-                        <a:t>PrePostPipelineEncoder (in-house)</a:t>
+                        <a:t>jinaai/jina-code-embeddings-0.5b</a:t>
                       </a:r>
                       <a:endParaRPr lang="en-US" sz="1300" dirty="0">
                         <a:latin typeface="Calibri" charset="0"/>
@@ -7588,7 +7609,7 @@
                           <a:ea typeface="Calibri" pitchFamily="34" charset="-122"/>
                           <a:cs typeface="Calibri" pitchFamily="34" charset="-120"/>
                         </a:rPr>
-                        <a:t>Config-driven, resource-aware wrapper with pre/post-processing hooks built for this submission</a:t>
+                        <a:t>Code-specific dense retrieval, nl2code_query / nl2code_document prompts</a:t>
                       </a:r>
                       <a:endParaRPr lang="en-US" sz="1300" dirty="0">
                         <a:latin typeface="Calibri" charset="0"/>
@@ -7658,7 +7679,7 @@
                           <a:ea typeface="Calibri" pitchFamily="34" charset="-122"/>
                           <a:cs typeface="Calibri" pitchFamily="34" charset="-120"/>
                         </a:rPr>
-                        <a:t>Embedding backbone</a:t>
+                        <a:t>Encoder framework</a:t>
                       </a:r>
                       <a:endParaRPr lang="en-US" sz="1300" dirty="0">
                         <a:latin typeface="Calibri" charset="0"/>
@@ -7726,7 +7747,7 @@
                           <a:ea typeface="Calibri" pitchFamily="34" charset="-122"/>
                           <a:cs typeface="Calibri" pitchFamily="34" charset="-120"/>
                         </a:rPr>
-                        <a:t>Benchmarked code-specialized dense embedding model</a:t>
+                        <a:t>sentence-transformers</a:t>
                       </a:r>
                       <a:endParaRPr lang="en-US" sz="1300" dirty="0">
                         <a:latin typeface="Calibri" charset="0"/>
@@ -7794,7 +7815,7 @@
                           <a:ea typeface="Calibri" pitchFamily="34" charset="-122"/>
                           <a:cs typeface="Calibri" pitchFamily="34" charset="-120"/>
                         </a:rPr>
-                        <a:t>Selected empirically out of 5 candidates via systematic evaluation, not a default pick</a:t>
+                        <a:t>Loads &amp; runs all candidate embedding models</a:t>
                       </a:r>
                       <a:endParaRPr lang="en-US" sz="1300" dirty="0">
                         <a:latin typeface="Calibri" charset="0"/>
@@ -8138,7 +8159,7 @@
                           <a:ea typeface="Calibri" pitchFamily="34" charset="-122"/>
                           <a:cs typeface="Calibri" pitchFamily="34" charset="-120"/>
                         </a:rPr>
-                        <a:t>Resource-aware, portable across CPU/GPU</a:t>
+                        <a:t>CUDA / Apple MPS / CPU</a:t>
                       </a:r>
                       <a:endParaRPr lang="en-US" sz="1300" dirty="0">
                         <a:latin typeface="Calibri" charset="0"/>
@@ -8206,7 +8227,7 @@
                           <a:ea typeface="Calibri" pitchFamily="34" charset="-122"/>
                           <a:cs typeface="Calibri" pitchFamily="34" charset="-120"/>
                         </a:rPr>
-                        <a:t>Pipeline auto-targets the best available device on any machine it runs on</a:t>
+                        <a:t>Device-aware pipeline; full-corpus inference on GPU, CPU/MPS supported</a:t>
                       </a:r>
                       <a:endParaRPr lang="en-US" sz="1300" dirty="0">
                         <a:latin typeface="Calibri" charset="0"/>
@@ -9082,7 +9103,7 @@
                 <a:ea typeface="Cambria" pitchFamily="34" charset="-122"/>
                 <a:cs typeface="Cambria" pitchFamily="34" charset="-120"/>
               </a:rPr>
-              <a:t>Five candidates benchmarked — real numbers, not a guess</a:t>
+              <a:t>Five models benchmarked — real numbers, not a guess</a:t>
             </a:r>
             <a:endParaRPr lang="en-US" sz="3200" dirty="0"/>
           </a:p>
@@ -9111,9 +9132,10 @@
             <a:tbl>
               <a:tblPr/>
               <a:tblGrid>
-                <a:gridCol w="3840480"/>
-                <a:gridCol w="1508760"/>
-                <a:gridCol w="1508760"/>
+                <a:gridCol w="3017520"/>
+                <a:gridCol w="1188720"/>
+                <a:gridCol w="1325880"/>
+                <a:gridCol w="1325880"/>
               </a:tblGrid>
               <a:tr h="502920">
                 <a:tc>
@@ -9133,7 +9155,75 @@
                           <a:ea typeface="Calibri" pitchFamily="34" charset="-122"/>
                           <a:cs typeface="Calibri" pitchFamily="34" charset="-120"/>
                         </a:rPr>
-                        <a:t>Candidate</a:t>
+                        <a:t>Model</a:t>
+                      </a:r>
+                      <a:endParaRPr lang="en-US" sz="1200" dirty="0">
+                        <a:latin typeface="Calibri" charset="0"/>
+                        <a:ea typeface="Calibri" charset="0"/>
+                        <a:cs typeface="Calibri" charset="0"/>
+                      </a:endParaRPr>
+                    </a:p>
+                  </a:txBody>
+                  <a:tcPr marL="91440" marR="91440" marT="45720" marB="45720">
+                    <a:lnL w="12700" cap="flat" cmpd="sng" algn="ctr">
+                      <a:solidFill>
+                        <a:srgbClr val="DDD6EC"/>
+                      </a:solidFill>
+                      <a:prstDash val="solid"/>
+                      <a:round/>
+                      <a:headEnd type="none" w="med" len="med"/>
+                      <a:tailEnd type="none" w="med" len="med"/>
+                    </a:lnL>
+                    <a:lnR w="12700" cap="flat" cmpd="sng" algn="ctr">
+                      <a:solidFill>
+                        <a:srgbClr val="DDD6EC"/>
+                      </a:solidFill>
+                      <a:prstDash val="solid"/>
+                      <a:round/>
+                      <a:headEnd type="none" w="med" len="med"/>
+                      <a:tailEnd type="none" w="med" len="med"/>
+                    </a:lnR>
+                    <a:lnT w="12700" cap="flat" cmpd="sng" algn="ctr">
+                      <a:solidFill>
+                        <a:srgbClr val="DDD6EC"/>
+                      </a:solidFill>
+                      <a:prstDash val="solid"/>
+                      <a:round/>
+                      <a:headEnd type="none" w="med" len="med"/>
+                      <a:tailEnd type="none" w="med" len="med"/>
+                    </a:lnT>
+                    <a:lnB w="12700" cap="flat" cmpd="sng" algn="ctr">
+                      <a:solidFill>
+                        <a:srgbClr val="DDD6EC"/>
+                      </a:solidFill>
+                      <a:prstDash val="solid"/>
+                      <a:round/>
+                      <a:headEnd type="none" w="med" len="med"/>
+                      <a:tailEnd type="none" w="med" len="med"/>
+                    </a:lnB>
+                    <a:solidFill>
+                      <a:srgbClr val="5B2A86"/>
+                    </a:solidFill>
+                  </a:tcPr>
+                </a:tc>
+                <a:tc>
+                  <a:txBody>
+                    <a:bodyPr/>
+                    <a:lstStyle/>
+                    <a:p>
+                      <a:pPr indent="0" marL="0">
+                        <a:buNone/>
+                      </a:pPr>
+                      <a:r>
+                        <a:rPr lang="en-US" sz="1200" b="1" dirty="0">
+                          <a:solidFill>
+                            <a:srgbClr val="FFFFFF"/>
+                          </a:solidFill>
+                          <a:latin typeface="Calibri" pitchFamily="34" charset="0"/>
+                          <a:ea typeface="Calibri" pitchFamily="34" charset="-122"/>
+                          <a:cs typeface="Calibri" pitchFamily="34" charset="-120"/>
+                        </a:rPr>
+                        <a:t>Device</a:t>
                       </a:r>
                       <a:endParaRPr lang="en-US" sz="1200" dirty="0">
                         <a:latin typeface="Calibri" charset="0"/>
@@ -9339,7 +9429,75 @@
                           <a:ea typeface="Calibri" pitchFamily="34" charset="-122"/>
                           <a:cs typeface="Calibri" pitchFamily="34" charset="-120"/>
                         </a:rPr>
-                        <a:t>Our selected engine</a:t>
+                        <a:t>jina-code-embeddings-0.5b</a:t>
+                      </a:r>
+                      <a:endParaRPr lang="en-US" sz="1200" dirty="0">
+                        <a:latin typeface="Calibri" charset="0"/>
+                        <a:ea typeface="Calibri" charset="0"/>
+                        <a:cs typeface="Calibri" charset="0"/>
+                      </a:endParaRPr>
+                    </a:p>
+                  </a:txBody>
+                  <a:tcPr marL="91440" marR="91440" marT="45720" marB="45720">
+                    <a:lnL w="12700" cap="flat" cmpd="sng" algn="ctr">
+                      <a:solidFill>
+                        <a:srgbClr val="DDD6EC"/>
+                      </a:solidFill>
+                      <a:prstDash val="solid"/>
+                      <a:round/>
+                      <a:headEnd type="none" w="med" len="med"/>
+                      <a:tailEnd type="none" w="med" len="med"/>
+                    </a:lnL>
+                    <a:lnR w="12700" cap="flat" cmpd="sng" algn="ctr">
+                      <a:solidFill>
+                        <a:srgbClr val="DDD6EC"/>
+                      </a:solidFill>
+                      <a:prstDash val="solid"/>
+                      <a:round/>
+                      <a:headEnd type="none" w="med" len="med"/>
+                      <a:tailEnd type="none" w="med" len="med"/>
+                    </a:lnR>
+                    <a:lnT w="12700" cap="flat" cmpd="sng" algn="ctr">
+                      <a:solidFill>
+                        <a:srgbClr val="DDD6EC"/>
+                      </a:solidFill>
+                      <a:prstDash val="solid"/>
+                      <a:round/>
+                      <a:headEnd type="none" w="med" len="med"/>
+                      <a:tailEnd type="none" w="med" len="med"/>
+                    </a:lnT>
+                    <a:lnB w="12700" cap="flat" cmpd="sng" algn="ctr">
+                      <a:solidFill>
+                        <a:srgbClr val="DDD6EC"/>
+                      </a:solidFill>
+                      <a:prstDash val="solid"/>
+                      <a:round/>
+                      <a:headEnd type="none" w="med" len="med"/>
+                      <a:tailEnd type="none" w="med" len="med"/>
+                    </a:lnB>
+                    <a:solidFill>
+                      <a:srgbClr val="FFFFFF"/>
+                    </a:solidFill>
+                  </a:tcPr>
+                </a:tc>
+                <a:tc>
+                  <a:txBody>
+                    <a:bodyPr/>
+                    <a:lstStyle/>
+                    <a:p>
+                      <a:pPr indent="0" marL="0">
+                        <a:buNone/>
+                      </a:pPr>
+                      <a:r>
+                        <a:rPr lang="en-US" sz="1200" dirty="0">
+                          <a:solidFill>
+                            <a:srgbClr val="1A1A2E"/>
+                          </a:solidFill>
+                          <a:latin typeface="Calibri" pitchFamily="34" charset="0"/>
+                          <a:ea typeface="Calibri" pitchFamily="34" charset="-122"/>
+                          <a:cs typeface="Calibri" pitchFamily="34" charset="-120"/>
+                        </a:rPr>
+                        <a:t>CUDA</a:t>
                       </a:r>
                       <a:endParaRPr lang="en-US" sz="1200" dirty="0">
                         <a:latin typeface="Calibri" charset="0"/>
@@ -9545,7 +9703,75 @@
                           <a:ea typeface="Calibri" pitchFamily="34" charset="-122"/>
                           <a:cs typeface="Calibri" pitchFamily="34" charset="-120"/>
                         </a:rPr>
-                        <a:t>Candidate 2 (code-specialized, mid-size)</a:t>
+                        <a:t>SFR-Embedding-Code-400M_R</a:t>
+                      </a:r>
+                      <a:endParaRPr lang="en-US" sz="1200" dirty="0">
+                        <a:latin typeface="Calibri" charset="0"/>
+                        <a:ea typeface="Calibri" charset="0"/>
+                        <a:cs typeface="Calibri" charset="0"/>
+                      </a:endParaRPr>
+                    </a:p>
+                  </a:txBody>
+                  <a:tcPr marL="91440" marR="91440" marT="45720" marB="45720">
+                    <a:lnL w="12700" cap="flat" cmpd="sng" algn="ctr">
+                      <a:solidFill>
+                        <a:srgbClr val="DDD6EC"/>
+                      </a:solidFill>
+                      <a:prstDash val="solid"/>
+                      <a:round/>
+                      <a:headEnd type="none" w="med" len="med"/>
+                      <a:tailEnd type="none" w="med" len="med"/>
+                    </a:lnL>
+                    <a:lnR w="12700" cap="flat" cmpd="sng" algn="ctr">
+                      <a:solidFill>
+                        <a:srgbClr val="DDD6EC"/>
+                      </a:solidFill>
+                      <a:prstDash val="solid"/>
+                      <a:round/>
+                      <a:headEnd type="none" w="med" len="med"/>
+                      <a:tailEnd type="none" w="med" len="med"/>
+                    </a:lnR>
+                    <a:lnT w="12700" cap="flat" cmpd="sng" algn="ctr">
+                      <a:solidFill>
+                        <a:srgbClr val="DDD6EC"/>
+                      </a:solidFill>
+                      <a:prstDash val="solid"/>
+                      <a:round/>
+                      <a:headEnd type="none" w="med" len="med"/>
+                      <a:tailEnd type="none" w="med" len="med"/>
+                    </a:lnT>
+                    <a:lnB w="12700" cap="flat" cmpd="sng" algn="ctr">
+                      <a:solidFill>
+                        <a:srgbClr val="DDD6EC"/>
+                      </a:solidFill>
+                      <a:prstDash val="solid"/>
+                      <a:round/>
+                      <a:headEnd type="none" w="med" len="med"/>
+                      <a:tailEnd type="none" w="med" len="med"/>
+                    </a:lnB>
+                    <a:solidFill>
+                      <a:srgbClr val="FFFFFF"/>
+                    </a:solidFill>
+                  </a:tcPr>
+                </a:tc>
+                <a:tc>
+                  <a:txBody>
+                    <a:bodyPr/>
+                    <a:lstStyle/>
+                    <a:p>
+                      <a:pPr indent="0" marL="0">
+                        <a:buNone/>
+                      </a:pPr>
+                      <a:r>
+                        <a:rPr lang="en-US" sz="1200" dirty="0">
+                          <a:solidFill>
+                            <a:srgbClr val="1A1A2E"/>
+                          </a:solidFill>
+                          <a:latin typeface="Calibri" pitchFamily="34" charset="0"/>
+                          <a:ea typeface="Calibri" pitchFamily="34" charset="-122"/>
+                          <a:cs typeface="Calibri" pitchFamily="34" charset="-120"/>
+                        </a:rPr>
+                        <a:t>CUDA</a:t>
                       </a:r>
                       <a:endParaRPr lang="en-US" sz="1200" dirty="0">
                         <a:latin typeface="Calibri" charset="0"/>
@@ -9751,7 +9977,75 @@
                           <a:ea typeface="Calibri" pitchFamily="34" charset="-122"/>
                           <a:cs typeface="Calibri" pitchFamily="34" charset="-120"/>
                         </a:rPr>
-                        <a:t>Candidate 3 (general-purpose, enterprise)</a:t>
+                        <a:t>granite-embedding-english-r2</a:t>
+                      </a:r>
+                      <a:endParaRPr lang="en-US" sz="1200" dirty="0">
+                        <a:latin typeface="Calibri" charset="0"/>
+                        <a:ea typeface="Calibri" charset="0"/>
+                        <a:cs typeface="Calibri" charset="0"/>
+                      </a:endParaRPr>
+                    </a:p>
+                  </a:txBody>
+                  <a:tcPr marL="91440" marR="91440" marT="45720" marB="45720">
+                    <a:lnL w="12700" cap="flat" cmpd="sng" algn="ctr">
+                      <a:solidFill>
+                        <a:srgbClr val="DDD6EC"/>
+                      </a:solidFill>
+                      <a:prstDash val="solid"/>
+                      <a:round/>
+                      <a:headEnd type="none" w="med" len="med"/>
+                      <a:tailEnd type="none" w="med" len="med"/>
+                    </a:lnL>
+                    <a:lnR w="12700" cap="flat" cmpd="sng" algn="ctr">
+                      <a:solidFill>
+                        <a:srgbClr val="DDD6EC"/>
+                      </a:solidFill>
+                      <a:prstDash val="solid"/>
+                      <a:round/>
+                      <a:headEnd type="none" w="med" len="med"/>
+                      <a:tailEnd type="none" w="med" len="med"/>
+                    </a:lnR>
+                    <a:lnT w="12700" cap="flat" cmpd="sng" algn="ctr">
+                      <a:solidFill>
+                        <a:srgbClr val="DDD6EC"/>
+                      </a:solidFill>
+                      <a:prstDash val="solid"/>
+                      <a:round/>
+                      <a:headEnd type="none" w="med" len="med"/>
+                      <a:tailEnd type="none" w="med" len="med"/>
+                    </a:lnT>
+                    <a:lnB w="12700" cap="flat" cmpd="sng" algn="ctr">
+                      <a:solidFill>
+                        <a:srgbClr val="DDD6EC"/>
+                      </a:solidFill>
+                      <a:prstDash val="solid"/>
+                      <a:round/>
+                      <a:headEnd type="none" w="med" len="med"/>
+                      <a:tailEnd type="none" w="med" len="med"/>
+                    </a:lnB>
+                    <a:solidFill>
+                      <a:srgbClr val="FFFFFF"/>
+                    </a:solidFill>
+                  </a:tcPr>
+                </a:tc>
+                <a:tc>
+                  <a:txBody>
+                    <a:bodyPr/>
+                    <a:lstStyle/>
+                    <a:p>
+                      <a:pPr indent="0" marL="0">
+                        <a:buNone/>
+                      </a:pPr>
+                      <a:r>
+                        <a:rPr lang="en-US" sz="1200" dirty="0">
+                          <a:solidFill>
+                            <a:srgbClr val="1A1A2E"/>
+                          </a:solidFill>
+                          <a:latin typeface="Calibri" pitchFamily="34" charset="0"/>
+                          <a:ea typeface="Calibri" pitchFamily="34" charset="-122"/>
+                          <a:cs typeface="Calibri" pitchFamily="34" charset="-120"/>
+                        </a:rPr>
+                        <a:t>CUDA</a:t>
                       </a:r>
                       <a:endParaRPr lang="en-US" sz="1200" dirty="0">
                         <a:latin typeface="Calibri" charset="0"/>
@@ -9957,7 +10251,75 @@
                           <a:ea typeface="Calibri" pitchFamily="34" charset="-122"/>
                           <a:cs typeface="Calibri" pitchFamily="34" charset="-120"/>
                         </a:rPr>
-                        <a:t>Candidate 4 (general-purpose, lightweight)</a:t>
+                        <a:t>e5-base-v2</a:t>
+                      </a:r>
+                      <a:endParaRPr lang="en-US" sz="1200" dirty="0">
+                        <a:latin typeface="Calibri" charset="0"/>
+                        <a:ea typeface="Calibri" charset="0"/>
+                        <a:cs typeface="Calibri" charset="0"/>
+                      </a:endParaRPr>
+                    </a:p>
+                  </a:txBody>
+                  <a:tcPr marL="91440" marR="91440" marT="45720" marB="45720">
+                    <a:lnL w="12700" cap="flat" cmpd="sng" algn="ctr">
+                      <a:solidFill>
+                        <a:srgbClr val="DDD6EC"/>
+                      </a:solidFill>
+                      <a:prstDash val="solid"/>
+                      <a:round/>
+                      <a:headEnd type="none" w="med" len="med"/>
+                      <a:tailEnd type="none" w="med" len="med"/>
+                    </a:lnL>
+                    <a:lnR w="12700" cap="flat" cmpd="sng" algn="ctr">
+                      <a:solidFill>
+                        <a:srgbClr val="DDD6EC"/>
+                      </a:solidFill>
+                      <a:prstDash val="solid"/>
+                      <a:round/>
+                      <a:headEnd type="none" w="med" len="med"/>
+                      <a:tailEnd type="none" w="med" len="med"/>
+                    </a:lnR>
+                    <a:lnT w="12700" cap="flat" cmpd="sng" algn="ctr">
+                      <a:solidFill>
+                        <a:srgbClr val="DDD6EC"/>
+                      </a:solidFill>
+                      <a:prstDash val="solid"/>
+                      <a:round/>
+                      <a:headEnd type="none" w="med" len="med"/>
+                      <a:tailEnd type="none" w="med" len="med"/>
+                    </a:lnT>
+                    <a:lnB w="12700" cap="flat" cmpd="sng" algn="ctr">
+                      <a:solidFill>
+                        <a:srgbClr val="DDD6EC"/>
+                      </a:solidFill>
+                      <a:prstDash val="solid"/>
+                      <a:round/>
+                      <a:headEnd type="none" w="med" len="med"/>
+                      <a:tailEnd type="none" w="med" len="med"/>
+                    </a:lnB>
+                    <a:solidFill>
+                      <a:srgbClr val="FFFFFF"/>
+                    </a:solidFill>
+                  </a:tcPr>
+                </a:tc>
+                <a:tc>
+                  <a:txBody>
+                    <a:bodyPr/>
+                    <a:lstStyle/>
+                    <a:p>
+                      <a:pPr indent="0" marL="0">
+                        <a:buNone/>
+                      </a:pPr>
+                      <a:r>
+                        <a:rPr lang="en-US" sz="1200" dirty="0">
+                          <a:solidFill>
+                            <a:srgbClr val="1A1A2E"/>
+                          </a:solidFill>
+                          <a:latin typeface="Calibri" pitchFamily="34" charset="0"/>
+                          <a:ea typeface="Calibri" pitchFamily="34" charset="-122"/>
+                          <a:cs typeface="Calibri" pitchFamily="34" charset="-120"/>
+                        </a:rPr>
+                        <a:t>CPU</a:t>
                       </a:r>
                       <a:endParaRPr lang="en-US" sz="1200" dirty="0">
                         <a:latin typeface="Calibri" charset="0"/>
@@ -10163,7 +10525,75 @@
                           <a:ea typeface="Calibri" pitchFamily="34" charset="-122"/>
                           <a:cs typeface="Calibri" pitchFamily="34" charset="-120"/>
                         </a:rPr>
-                        <a:t>Candidate 5 (baseline)</a:t>
+                        <a:t>all-MiniLM-L6-v2 (baseline)</a:t>
+                      </a:r>
+                      <a:endParaRPr lang="en-US" sz="1200" dirty="0">
+                        <a:latin typeface="Calibri" charset="0"/>
+                        <a:ea typeface="Calibri" charset="0"/>
+                        <a:cs typeface="Calibri" charset="0"/>
+                      </a:endParaRPr>
+                    </a:p>
+                  </a:txBody>
+                  <a:tcPr marL="91440" marR="91440" marT="45720" marB="45720">
+                    <a:lnL w="12700" cap="flat" cmpd="sng" algn="ctr">
+                      <a:solidFill>
+                        <a:srgbClr val="DDD6EC"/>
+                      </a:solidFill>
+                      <a:prstDash val="solid"/>
+                      <a:round/>
+                      <a:headEnd type="none" w="med" len="med"/>
+                      <a:tailEnd type="none" w="med" len="med"/>
+                    </a:lnL>
+                    <a:lnR w="12700" cap="flat" cmpd="sng" algn="ctr">
+                      <a:solidFill>
+                        <a:srgbClr val="DDD6EC"/>
+                      </a:solidFill>
+                      <a:prstDash val="solid"/>
+                      <a:round/>
+                      <a:headEnd type="none" w="med" len="med"/>
+                      <a:tailEnd type="none" w="med" len="med"/>
+                    </a:lnR>
+                    <a:lnT w="12700" cap="flat" cmpd="sng" algn="ctr">
+                      <a:solidFill>
+                        <a:srgbClr val="DDD6EC"/>
+                      </a:solidFill>
+                      <a:prstDash val="solid"/>
+                      <a:round/>
+                      <a:headEnd type="none" w="med" len="med"/>
+                      <a:tailEnd type="none" w="med" len="med"/>
+                    </a:lnT>
+                    <a:lnB w="12700" cap="flat" cmpd="sng" algn="ctr">
+                      <a:solidFill>
+                        <a:srgbClr val="DDD6EC"/>
+                      </a:solidFill>
+                      <a:prstDash val="solid"/>
+                      <a:round/>
+                      <a:headEnd type="none" w="med" len="med"/>
+                      <a:tailEnd type="none" w="med" len="med"/>
+                    </a:lnB>
+                    <a:solidFill>
+                      <a:srgbClr val="FFFFFF"/>
+                    </a:solidFill>
+                  </a:tcPr>
+                </a:tc>
+                <a:tc>
+                  <a:txBody>
+                    <a:bodyPr/>
+                    <a:lstStyle/>
+                    <a:p>
+                      <a:pPr indent="0" marL="0">
+                        <a:buNone/>
+                      </a:pPr>
+                      <a:r>
+                        <a:rPr lang="en-US" sz="1200" dirty="0">
+                          <a:solidFill>
+                            <a:srgbClr val="1A1A2E"/>
+                          </a:solidFill>
+                          <a:latin typeface="Calibri" pitchFamily="34" charset="0"/>
+                          <a:ea typeface="Calibri" pitchFamily="34" charset="-122"/>
+                          <a:cs typeface="Calibri" pitchFamily="34" charset="-120"/>
+                        </a:rPr>
+                        <a:t>CPU</a:t>
                       </a:r>
                       <a:endParaRPr lang="en-US" sz="1200" dirty="0">
                         <a:latin typeface="Calibri" charset="0"/>
@@ -10388,7 +10818,7 @@
                 <a:ea typeface="Calibri" pitchFamily="34" charset="-122"/>
                 <a:cs typeface="Calibri" pitchFamily="34" charset="-120"/>
               </a:rPr>
-              <a:t>~6x the next-best candidate, ~12.7x the baseline — achieved through systematic benchmarking, correct prompt-template usage, and a pipeline built to use the backbone as intended, not a default call.</a:t>
+              <a:t>~6x the next-best candidate, ~12.7x the baseline — achieved through systematic benchmarking and correct prompt-template usage, not a default call.</a:t>
             </a:r>
             <a:endParaRPr lang="en-US" sz="1250" dirty="0"/>
           </a:p>

</xml_diff>